<commit_message>
polish: refine presentation wording and layout
</commit_message>
<xml_diff>
--- a/docs/presentation_30min/tpm_course_design_30min.pptx
+++ b/docs/presentation_30min/tpm_course_design_30min.pptx
@@ -2664,7 +2664,7 @@
         <p:spPr>
           <a:xfrm>
             <a:off x="896112" y="1481328"/>
-            <a:ext cx="4389120" cy="182880"/>
+            <a:ext cx="5303520" cy="219456"/>
           </a:xfrm>
           <a:prstGeom prst="rect">
             <a:avLst/>
@@ -2680,7 +2680,7 @@
               <a:buNone/>
             </a:pPr>
             <a:r>
-              <a:rPr lang="en-US" sz="1600" dirty="0">
+              <a:rPr lang="en-US" sz="1350" dirty="0">
                 <a:solidFill>
                   <a:srgbClr val="C8D7EC"/>
                 </a:solidFill>
@@ -2688,9 +2688,9 @@
                 <a:ea typeface="Microsoft YaHei" pitchFamily="34" charset="-122"/>
                 <a:cs typeface="Microsoft YaHei" pitchFamily="34" charset="-120"/>
               </a:rPr>
-              <a:t>30 分钟课程设计答辩 PPT</a:t>
-            </a:r>
-            <a:endParaRPr lang="en-US" sz="1600" dirty="0"/>
+              <a:t>基于 TPM 2.0 的可信度量、密封、远程证明与 PKCS#11 实现</a:t>
+            </a:r>
+            <a:endParaRPr lang="en-US" sz="1350" dirty="0"/>
           </a:p>
         </p:txBody>
       </p:sp>
@@ -3096,7 +3096,7 @@
                 <a:ea typeface="Microsoft YaHei" pitchFamily="34" charset="-122"/>
                 <a:cs typeface="Microsoft YaHei" pitchFamily="34" charset="-120"/>
               </a:rPr>
-              <a:t>本次交付物</a:t>
+              <a:t>报告重点</a:t>
             </a:r>
             <a:endParaRPr lang="en-US" sz="1400" dirty="0"/>
           </a:p>
@@ -3136,7 +3136,7 @@
                 <a:ea typeface="Microsoft YaHei" pitchFamily="34" charset="-122"/>
                 <a:cs typeface="Microsoft YaHei" pitchFamily="34" charset="-120"/>
               </a:rPr>
-              <a:t>一份 20 页左右、面向 30 分钟答辩节奏的 PowerPoint。</a:t>
+              <a:t>按脚本顺序讲清系统如何从环境搭建走到完整可信链路。</a:t>
             </a:r>
             <a:endParaRPr lang="en-US" sz="1500" dirty="0"/>
           </a:p>
@@ -3154,7 +3154,7 @@
                 <a:ea typeface="Microsoft YaHei" pitchFamily="34" charset="-122"/>
                 <a:cs typeface="Microsoft YaHei" pitchFamily="34" charset="-120"/>
               </a:rPr>
-              <a:t>一篇逐页对应的演讲稿，保证讲解顺序和 slide 一致。</a:t>
+              <a:t>把 PCR、Policy、Quote 与 Token 这些理论名词落到具体代码和命令。</a:t>
             </a:r>
             <a:endParaRPr lang="en-US" sz="1500" dirty="0"/>
           </a:p>
@@ -3172,7 +3172,7 @@
                 <a:ea typeface="Microsoft YaHei" pitchFamily="34" charset="-122"/>
                 <a:cs typeface="Microsoft YaHei" pitchFamily="34" charset="-120"/>
               </a:rPr>
-              <a:t>保留可编辑的 JS 源文件，后续可以继续改版。</a:t>
+              <a:t>结合真实实验输出，说明可信状态与篡改状态的结果差异。</a:t>
             </a:r>
             <a:endParaRPr lang="en-US" sz="1500" dirty="0"/>
           </a:p>
@@ -3577,7 +3577,7 @@
                 <a:ea typeface="Microsoft YaHei" pitchFamily="34" charset="-122"/>
                 <a:cs typeface="Microsoft YaHei" pitchFamily="34" charset="-120"/>
               </a:rPr>
-              <a:t>TPM 安全文件保险箱课程设计答辩</a:t>
+              <a:t>TPM 安全文件保险箱</a:t>
             </a:r>
             <a:endParaRPr lang="en-US" sz="900" dirty="0"/>
           </a:p>
@@ -4518,7 +4518,7 @@
                 <a:ea typeface="Microsoft YaHei" pitchFamily="34" charset="-122"/>
                 <a:cs typeface="Microsoft YaHei" pitchFamily="34" charset="-120"/>
               </a:rPr>
-              <a:t>TPM 安全文件保险箱课程设计答辩</a:t>
+              <a:t>TPM 安全文件保险箱</a:t>
             </a:r>
             <a:endParaRPr lang="en-US" sz="900" dirty="0"/>
           </a:p>
@@ -5080,7 +5080,7 @@
               </a:rPr>
               <a:t> pcr.policy</a:t>
             </a:r>
-            <a:endParaRPr lang="en-US" sz="1050" dirty="0"/>
+            <a:endParaRPr lang="en-US" sz="1000" dirty="0"/>
           </a:p>
         </p:txBody>
       </p:sp>
@@ -5795,7 +5795,7 @@
               </a:rPr>
               <a:t> session:session.ctx</a:t>
             </a:r>
-            <a:endParaRPr lang="en-US" sz="1050" dirty="0"/>
+            <a:endParaRPr lang="en-US" sz="1000" dirty="0"/>
           </a:p>
         </p:txBody>
       </p:sp>
@@ -6316,7 +6316,7 @@
                 <a:ea typeface="Microsoft YaHei" pitchFamily="34" charset="-122"/>
                 <a:cs typeface="Microsoft YaHei" pitchFamily="34" charset="-120"/>
               </a:rPr>
-              <a:t>TPM 安全文件保险箱课程设计答辩</a:t>
+              <a:t>TPM 安全文件保险箱</a:t>
             </a:r>
             <a:endParaRPr lang="en-US" sz="900" dirty="0"/>
           </a:p>
@@ -7465,7 +7465,7 @@
                 <a:ea typeface="Microsoft YaHei" pitchFamily="34" charset="-122"/>
                 <a:cs typeface="Microsoft YaHei" pitchFamily="34" charset="-120"/>
               </a:rPr>
-              <a:t>TPM 安全文件保险箱课程设计答辩</a:t>
+              <a:t>TPM 安全文件保险箱</a:t>
             </a:r>
             <a:endParaRPr lang="en-US" sz="900" dirty="0"/>
           </a:p>
@@ -8345,7 +8345,7 @@
               </a:rPr>
               <a:t> sha256</a:t>
             </a:r>
-            <a:endParaRPr lang="en-US" sz="1050" dirty="0"/>
+            <a:endParaRPr lang="en-US" sz="1000" dirty="0"/>
           </a:p>
         </p:txBody>
       </p:sp>
@@ -9012,7 +9012,7 @@
               </a:rPr>
               <a:t>"</a:t>
             </a:r>
-            <a:endParaRPr lang="en-US" sz="1050" dirty="0"/>
+            <a:endParaRPr lang="en-US" sz="1000" dirty="0"/>
           </a:p>
         </p:txBody>
       </p:sp>
@@ -9638,7 +9638,7 @@
                 <a:ea typeface="Microsoft YaHei" pitchFamily="34" charset="-122"/>
                 <a:cs typeface="Microsoft YaHei" pitchFamily="34" charset="-120"/>
               </a:rPr>
-              <a:t>TPM 安全文件保险箱课程设计答辩</a:t>
+              <a:t>TPM 安全文件保险箱</a:t>
             </a:r>
             <a:endParaRPr lang="en-US" sz="900" dirty="0"/>
           </a:p>
@@ -10559,7 +10559,7 @@
                 <a:ea typeface="Microsoft YaHei" pitchFamily="34" charset="-122"/>
                 <a:cs typeface="Microsoft YaHei" pitchFamily="34" charset="-120"/>
               </a:rPr>
-              <a:t>TPM 安全文件保险箱课程设计答辩</a:t>
+              <a:t>TPM 安全文件保险箱</a:t>
             </a:r>
             <a:endParaRPr lang="en-US" sz="900" dirty="0"/>
           </a:p>
@@ -10889,11 +10889,11 @@
         <p:spPr>
           <a:xfrm>
             <a:off x="749808" y="3063240"/>
-            <a:ext cx="6537960" cy="2926080"/>
+            <a:ext cx="6537960" cy="3154680"/>
           </a:xfrm>
           <a:prstGeom prst="roundRect">
             <a:avLst>
-              <a:gd name="adj" fmla="val 1563"/>
+              <a:gd name="adj" fmla="val 1449"/>
             </a:avLst>
           </a:prstGeom>
           <a:solidFill>
@@ -10955,7 +10955,7 @@
         <p:spPr>
           <a:xfrm>
             <a:off x="877824" y="3319272"/>
-            <a:ext cx="6281928" cy="2596896"/>
+            <a:ext cx="6281928" cy="2825496"/>
           </a:xfrm>
           <a:prstGeom prst="rect">
             <a:avLst/>
@@ -12467,7 +12467,7 @@
               </a:rPr>
               <a:t>)</a:t>
             </a:r>
-            <a:endParaRPr lang="en-US" sz="1050" dirty="0"/>
+            <a:endParaRPr lang="en-US" sz="1000" dirty="0"/>
           </a:p>
         </p:txBody>
       </p:sp>
@@ -12480,11 +12480,11 @@
         <p:spPr>
           <a:xfrm>
             <a:off x="7498080" y="3063240"/>
-            <a:ext cx="3977640" cy="2926080"/>
+            <a:ext cx="3977640" cy="3154680"/>
           </a:xfrm>
           <a:prstGeom prst="roundRect">
             <a:avLst>
-              <a:gd name="adj" fmla="val 1875"/>
+              <a:gd name="adj" fmla="val 1739"/>
             </a:avLst>
           </a:prstGeom>
           <a:solidFill>
@@ -12934,7 +12934,7 @@
                 <a:ea typeface="Microsoft YaHei" pitchFamily="34" charset="-122"/>
                 <a:cs typeface="Microsoft YaHei" pitchFamily="34" charset="-120"/>
               </a:rPr>
-              <a:t>TPM 安全文件保险箱课程设计答辩</a:t>
+              <a:t>TPM 安全文件保险箱</a:t>
             </a:r>
             <a:endParaRPr lang="en-US" sz="900" dirty="0"/>
           </a:p>
@@ -13465,7 +13465,7 @@
                 <a:ea typeface="Microsoft YaHei" pitchFamily="34" charset="-122"/>
                 <a:cs typeface="Microsoft YaHei" pitchFamily="34" charset="-120"/>
               </a:rPr>
-              <a:t>把“脚本功能”升级成“系统流程”，更适合答辩展示。</a:t>
+              <a:t>把“脚本功能”升级成“系统流程”，更适合完整展示。</a:t>
             </a:r>
             <a:endParaRPr lang="en-US" sz="1360" dirty="0"/>
           </a:p>
@@ -13826,7 +13826,7 @@
                 <a:ea typeface="Microsoft YaHei" pitchFamily="34" charset="-122"/>
                 <a:cs typeface="Microsoft YaHei" pitchFamily="34" charset="-120"/>
               </a:rPr>
-              <a:t>答辩里不能只讲业务脚本，还要讲这些让系统稳定运行的基础层。</a:t>
+              <a:t>除了业务脚本，还要讲这些让系统稳定运行的基础层。</a:t>
             </a:r>
             <a:endParaRPr lang="en-US" sz="1100" dirty="0"/>
           </a:p>
@@ -13970,7 +13970,7 @@
                 <a:ea typeface="Microsoft YaHei" pitchFamily="34" charset="-122"/>
                 <a:cs typeface="Microsoft YaHei" pitchFamily="34" charset="-120"/>
               </a:rPr>
-              <a:t>TPM 安全文件保险箱课程设计答辩</a:t>
+              <a:t>TPM 安全文件保险箱</a:t>
             </a:r>
             <a:endParaRPr lang="en-US" sz="900" dirty="0"/>
           </a:p>
@@ -13985,11 +13985,11 @@
         <p:spPr>
           <a:xfrm>
             <a:off x="713232" y="1280160"/>
-            <a:ext cx="5486400" cy="2103120"/>
+            <a:ext cx="5486400" cy="2331720"/>
           </a:xfrm>
           <a:prstGeom prst="roundRect">
             <a:avLst>
-              <a:gd name="adj" fmla="val 2174"/>
+              <a:gd name="adj" fmla="val 1961"/>
             </a:avLst>
           </a:prstGeom>
           <a:solidFill>
@@ -14051,7 +14051,7 @@
         <p:spPr>
           <a:xfrm>
             <a:off x="841248" y="1536192"/>
-            <a:ext cx="5230368" cy="1773936"/>
+            <a:ext cx="5230368" cy="2002536"/>
           </a:xfrm>
           <a:prstGeom prst="rect">
             <a:avLst/>
@@ -14614,7 +14614,7 @@
               </a:rPr>
               <a:t>/pkcs11-store"</a:t>
             </a:r>
-            <a:endParaRPr lang="en-US" sz="1050" dirty="0"/>
+            <a:endParaRPr lang="en-US" sz="1000" dirty="0"/>
           </a:p>
         </p:txBody>
       </p:sp>
@@ -14627,11 +14627,11 @@
         <p:spPr>
           <a:xfrm>
             <a:off x="713232" y="3675888"/>
-            <a:ext cx="5486400" cy="2331720"/>
+            <a:ext cx="5486400" cy="2514600"/>
           </a:xfrm>
           <a:prstGeom prst="roundRect">
             <a:avLst>
-              <a:gd name="adj" fmla="val 1961"/>
+              <a:gd name="adj" fmla="val 1818"/>
             </a:avLst>
           </a:prstGeom>
           <a:solidFill>
@@ -14693,7 +14693,7 @@
         <p:spPr>
           <a:xfrm>
             <a:off x="841248" y="3931920"/>
-            <a:ext cx="5230368" cy="2002536"/>
+            <a:ext cx="5230368" cy="2185416"/>
           </a:xfrm>
           <a:prstGeom prst="rect">
             <a:avLst/>
@@ -15600,7 +15600,7 @@
               </a:rPr>
               <a:t>}</a:t>
             </a:r>
-            <a:endParaRPr lang="en-US" sz="1050" dirty="0"/>
+            <a:endParaRPr lang="en-US" sz="1000" dirty="0"/>
           </a:p>
         </p:txBody>
       </p:sp>
@@ -16085,7 +16085,7 @@
                 <a:ea typeface="Microsoft YaHei" pitchFamily="34" charset="-122"/>
                 <a:cs typeface="Microsoft YaHei" pitchFamily="34" charset="-120"/>
               </a:rPr>
-              <a:t>TPM 安全文件保险箱课程设计答辩</a:t>
+              <a:t>TPM 安全文件保险箱</a:t>
             </a:r>
             <a:endParaRPr lang="en-US" sz="900" dirty="0"/>
           </a:p>
@@ -16832,7 +16832,7 @@
                 <a:ea typeface="Microsoft YaHei" pitchFamily="34" charset="-122"/>
                 <a:cs typeface="Microsoft YaHei" pitchFamily="34" charset="-120"/>
               </a:rPr>
-              <a:t>TPM 安全文件保险箱课程设计答辩</a:t>
+              <a:t>TPM 安全文件保险箱</a:t>
             </a:r>
             <a:endParaRPr lang="en-US" sz="900" dirty="0"/>
           </a:p>
@@ -16912,7 +16912,7 @@
         </p:nvSpPr>
         <p:spPr>
           <a:xfrm>
-            <a:off x="932688" y="1554480"/>
+            <a:off x="932688" y="1755648"/>
             <a:ext cx="4983480" cy="128016"/>
           </a:xfrm>
           <a:prstGeom prst="rect">
@@ -16929,7 +16929,7 @@
               <a:buNone/>
             </a:pPr>
             <a:r>
-              <a:rPr lang="en-US" sz="1500" b="1" dirty="0">
+              <a:rPr lang="en-US" sz="1250" b="1" dirty="0">
                 <a:solidFill>
                   <a:srgbClr val="2E8B57"/>
                 </a:solidFill>
@@ -16937,9 +16937,9 @@
                 <a:ea typeface="Microsoft YaHei" pitchFamily="34" charset="-122"/>
                 <a:cs typeface="Microsoft YaHei" pitchFamily="34" charset="-120"/>
               </a:rPr>
-              <a:t>06_full_demo 的关键输出</a:t>
-            </a:r>
-            <a:endParaRPr lang="en-US" sz="1500" dirty="0"/>
+              <a:t>关键输出摘录</a:t>
+            </a:r>
+            <a:endParaRPr lang="en-US" sz="1250" dirty="0"/>
           </a:p>
         </p:txBody>
       </p:sp>
@@ -16951,8 +16951,8 @@
         </p:nvSpPr>
         <p:spPr>
           <a:xfrm>
-            <a:off x="932688" y="1874520"/>
-            <a:ext cx="4846320" cy="3474720"/>
+            <a:off x="932688" y="2029968"/>
+            <a:ext cx="4846320" cy="3246120"/>
           </a:xfrm>
           <a:prstGeom prst="rect">
             <a:avLst/>
@@ -17113,7 +17113,7 @@
         </p:nvSpPr>
         <p:spPr>
           <a:xfrm>
-            <a:off x="6537960" y="1554480"/>
+            <a:off x="6537960" y="1755648"/>
             <a:ext cx="4663440" cy="128016"/>
           </a:xfrm>
           <a:prstGeom prst="rect">
@@ -17130,7 +17130,7 @@
               <a:buNone/>
             </a:pPr>
             <a:r>
-              <a:rPr lang="en-US" sz="1500" b="1" dirty="0">
+              <a:rPr lang="en-US" sz="1250" b="1" dirty="0">
                 <a:solidFill>
                   <a:srgbClr val="C0392B"/>
                 </a:solidFill>
@@ -17138,9 +17138,9 @@
                 <a:ea typeface="Microsoft YaHei" pitchFamily="34" charset="-122"/>
                 <a:cs typeface="Microsoft YaHei" pitchFamily="34" charset="-120"/>
               </a:rPr>
-              <a:t>攻击模拟的关键输出</a:t>
-            </a:r>
-            <a:endParaRPr lang="en-US" sz="1500" dirty="0"/>
+              <a:t>关键输出摘录</a:t>
+            </a:r>
+            <a:endParaRPr lang="en-US" sz="1250" dirty="0"/>
           </a:p>
         </p:txBody>
       </p:sp>
@@ -17152,8 +17152,8 @@
         </p:nvSpPr>
         <p:spPr>
           <a:xfrm>
-            <a:off x="6537960" y="1874520"/>
-            <a:ext cx="4526280" cy="3474720"/>
+            <a:off x="6537960" y="2029968"/>
+            <a:ext cx="4526280" cy="3246120"/>
           </a:xfrm>
           <a:prstGeom prst="rect">
             <a:avLst/>
@@ -17401,7 +17401,7 @@
                 <a:ea typeface="Microsoft YaHei" pitchFamily="34" charset="-122"/>
                 <a:cs typeface="Microsoft YaHei" pitchFamily="34" charset="-120"/>
               </a:rPr>
-              <a:t>汇报路线与时间分配</a:t>
+              <a:t>汇报路线</a:t>
             </a:r>
             <a:endParaRPr lang="en-US" sz="2200" dirty="0"/>
           </a:p>
@@ -17440,7 +17440,7 @@
                 <a:ea typeface="Microsoft YaHei" pitchFamily="34" charset="-122"/>
                 <a:cs typeface="Microsoft YaHei" pitchFamily="34" charset="-120"/>
               </a:rPr>
-              <a:t>先给出 30 分钟节奏，再按这个顺序展开。</a:t>
+              <a:t>按照系统目标、脚本实现、理论落地、实验结果四条线展开。</a:t>
             </a:r>
             <a:endParaRPr lang="en-US" sz="1100" dirty="0"/>
           </a:p>
@@ -17584,7 +17584,7 @@
                 <a:ea typeface="Microsoft YaHei" pitchFamily="34" charset="-122"/>
                 <a:cs typeface="Microsoft YaHei" pitchFamily="34" charset="-120"/>
               </a:rPr>
-              <a:t>TPM 安全文件保险箱课程设计答辩</a:t>
+              <a:t>TPM 安全文件保险箱</a:t>
             </a:r>
             <a:endParaRPr lang="en-US" sz="900" dirty="0"/>
           </a:p>
@@ -17794,7 +17794,7 @@
                 <a:ea typeface="Microsoft YaHei" pitchFamily="34" charset="-122"/>
                 <a:cs typeface="Microsoft YaHei" pitchFamily="34" charset="-120"/>
               </a:rPr>
-              <a:t>约 4 分钟</a:t>
+              <a:t>目标</a:t>
             </a:r>
             <a:endParaRPr lang="en-US" sz="1150" dirty="0"/>
           </a:p>
@@ -18004,7 +18004,7 @@
                 <a:ea typeface="Microsoft YaHei" pitchFamily="34" charset="-122"/>
                 <a:cs typeface="Microsoft YaHei" pitchFamily="34" charset="-120"/>
               </a:rPr>
-              <a:t>约 8 分钟</a:t>
+              <a:t>脚本</a:t>
             </a:r>
             <a:endParaRPr lang="en-US" sz="1150" dirty="0"/>
           </a:p>
@@ -18214,7 +18214,7 @@
                 <a:ea typeface="Microsoft YaHei" pitchFamily="34" charset="-122"/>
                 <a:cs typeface="Microsoft YaHei" pitchFamily="34" charset="-120"/>
               </a:rPr>
-              <a:t>约 10 分钟</a:t>
+              <a:t>理论</a:t>
             </a:r>
             <a:endParaRPr lang="en-US" sz="1150" dirty="0"/>
           </a:p>
@@ -18424,7 +18424,7 @@
                 <a:ea typeface="Microsoft YaHei" pitchFamily="34" charset="-122"/>
                 <a:cs typeface="Microsoft YaHei" pitchFamily="34" charset="-120"/>
               </a:rPr>
-              <a:t>约 5 分钟</a:t>
+              <a:t>结果</a:t>
             </a:r>
             <a:endParaRPr lang="en-US" sz="1150" dirty="0"/>
           </a:p>
@@ -18634,7 +18634,7 @@
                 <a:ea typeface="Microsoft YaHei" pitchFamily="34" charset="-122"/>
                 <a:cs typeface="Microsoft YaHei" pitchFamily="34" charset="-120"/>
               </a:rPr>
-              <a:t>约 3 分钟</a:t>
+              <a:t>总结</a:t>
             </a:r>
             <a:endParaRPr lang="en-US" sz="1150" dirty="0"/>
           </a:p>
@@ -18700,7 +18700,7 @@
                 <a:ea typeface="Microsoft YaHei" pitchFamily="34" charset="-122"/>
                 <a:cs typeface="Microsoft YaHei" pitchFamily="34" charset="-120"/>
               </a:rPr>
-              <a:t>节奏提醒</a:t>
+              <a:t>阅读提示</a:t>
             </a:r>
             <a:endParaRPr lang="en-US" sz="1400" dirty="0"/>
           </a:p>
@@ -18714,24 +18714,24 @@
         </p:nvSpPr>
         <p:spPr>
           <a:xfrm>
-            <a:off x="10698480" y="1664208"/>
-            <a:ext cx="731520" cy="4023360"/>
-          </a:xfrm>
-          <a:prstGeom prst="rect">
-            <a:avLst/>
-          </a:prstGeom>
-          <a:noFill/>
-          <a:ln/>
-        </p:spPr>
-        <p:txBody>
-          <a:bodyPr wrap="square" lIns="381" tIns="381" rIns="381" bIns="381" rtlCol="0" anchor="ctr"/>
-          <a:lstStyle/>
-          <a:p>
-            <a:pPr indent="0" marL="0">
-              <a:buNone/>
-            </a:pPr>
-            <a:r>
-              <a:rPr lang="en-US" sz="1100" dirty="0">
+            <a:off x="10698480" y="2148840"/>
+            <a:ext cx="731520" cy="2834640"/>
+          </a:xfrm>
+          <a:prstGeom prst="rect">
+            <a:avLst/>
+          </a:prstGeom>
+          <a:noFill/>
+          <a:ln/>
+        </p:spPr>
+        <p:txBody>
+          <a:bodyPr wrap="square" lIns="254" tIns="254" rIns="254" bIns="254" rtlCol="0" anchor="ctr"/>
+          <a:lstStyle/>
+          <a:p>
+            <a:pPr algn="ctr" indent="0" marL="0">
+              <a:buNone/>
+            </a:pPr>
+            <a:r>
+              <a:rPr lang="en-US" sz="1350" dirty="0">
                 <a:solidFill>
                   <a:srgbClr val="24364B"/>
                 </a:solidFill>
@@ -18739,9 +18739,60 @@
                 <a:ea typeface="Microsoft YaHei" pitchFamily="34" charset="-122"/>
                 <a:cs typeface="Microsoft YaHei" pitchFamily="34" charset="-120"/>
               </a:rPr>
-              <a:t>前半段讲“系统是怎么搭起来并跑起来的”，后半段讲“理论怎么落到代码上，以及实验结果说明了什么”。</a:t>
-            </a:r>
-            <a:endParaRPr lang="en-US" sz="1100" dirty="0"/>
+              <a:t>先看目标</a:t>
+            </a:r>
+            <a:endParaRPr lang="en-US" sz="1350" dirty="0"/>
+          </a:p>
+          <a:p>
+            <a:pPr algn="ctr" indent="0" marL="0">
+              <a:buNone/>
+            </a:pPr>
+            <a:r>
+              <a:rPr lang="en-US" sz="1350" dirty="0">
+                <a:solidFill>
+                  <a:srgbClr val="24364B"/>
+                </a:solidFill>
+                <a:latin typeface="Microsoft YaHei" pitchFamily="34" charset="0"/>
+                <a:ea typeface="Microsoft YaHei" pitchFamily="34" charset="-122"/>
+                <a:cs typeface="Microsoft YaHei" pitchFamily="34" charset="-120"/>
+              </a:rPr>
+              <a:t>再看脚本</a:t>
+            </a:r>
+            <a:endParaRPr lang="en-US" sz="1350" dirty="0"/>
+          </a:p>
+          <a:p>
+            <a:pPr algn="ctr" indent="0" marL="0">
+              <a:buNone/>
+            </a:pPr>
+            <a:r>
+              <a:rPr lang="en-US" sz="1350" dirty="0">
+                <a:solidFill>
+                  <a:srgbClr val="24364B"/>
+                </a:solidFill>
+                <a:latin typeface="Microsoft YaHei" pitchFamily="34" charset="0"/>
+                <a:ea typeface="Microsoft YaHei" pitchFamily="34" charset="-122"/>
+                <a:cs typeface="Microsoft YaHei" pitchFamily="34" charset="-120"/>
+              </a:rPr>
+              <a:t>再看理论</a:t>
+            </a:r>
+            <a:endParaRPr lang="en-US" sz="1350" dirty="0"/>
+          </a:p>
+          <a:p>
+            <a:pPr algn="ctr" indent="0" marL="0">
+              <a:buNone/>
+            </a:pPr>
+            <a:r>
+              <a:rPr lang="en-US" sz="1350" dirty="0">
+                <a:solidFill>
+                  <a:srgbClr val="24364B"/>
+                </a:solidFill>
+                <a:latin typeface="Microsoft YaHei" pitchFamily="34" charset="0"/>
+                <a:ea typeface="Microsoft YaHei" pitchFamily="34" charset="-122"/>
+                <a:cs typeface="Microsoft YaHei" pitchFamily="34" charset="-120"/>
+              </a:rPr>
+              <a:t>最后看结果</a:t>
+            </a:r>
+            <a:endParaRPr lang="en-US" sz="1350" dirty="0"/>
           </a:p>
         </p:txBody>
       </p:sp>
@@ -19066,7 +19117,7 @@
                 <a:ea typeface="Microsoft YaHei" pitchFamily="34" charset="-122"/>
                 <a:cs typeface="Microsoft YaHei" pitchFamily="34" charset="-120"/>
               </a:rPr>
-              <a:t>TPM 安全文件保险箱课程设计答辩</a:t>
+              <a:t>TPM 安全文件保险箱</a:t>
             </a:r>
             <a:endParaRPr lang="en-US" sz="900" dirty="0"/>
           </a:p>
@@ -19797,7 +19848,7 @@
                 <a:ea typeface="Microsoft YaHei" pitchFamily="34" charset="-122"/>
                 <a:cs typeface="Microsoft YaHei" pitchFamily="34" charset="-120"/>
               </a:rPr>
-              <a:t>TPM 安全文件保险箱课程设计答辩</a:t>
+              <a:t>TPM 安全文件保险箱</a:t>
             </a:r>
             <a:endParaRPr lang="en-US" sz="900" dirty="0"/>
           </a:p>
@@ -20773,7 +20824,7 @@
                 <a:ea typeface="Microsoft YaHei" pitchFamily="34" charset="-122"/>
                 <a:cs typeface="Microsoft YaHei" pitchFamily="34" charset="-120"/>
               </a:rPr>
-              <a:t>TPM 安全文件保险箱课程设计答辩</a:t>
+              <a:t>TPM 安全文件保险箱</a:t>
             </a:r>
             <a:endParaRPr lang="en-US" sz="900" dirty="0"/>
           </a:p>
@@ -22099,7 +22150,7 @@
                 <a:ea typeface="Microsoft YaHei" pitchFamily="34" charset="-122"/>
                 <a:cs typeface="Microsoft YaHei" pitchFamily="34" charset="-120"/>
               </a:rPr>
-              <a:t>TPM 安全文件保险箱课程设计答辩</a:t>
+              <a:t>TPM 安全文件保险箱</a:t>
             </a:r>
             <a:endParaRPr lang="en-US" sz="900" dirty="0"/>
           </a:p>
@@ -23761,7 +23812,7 @@
                 <a:ea typeface="Microsoft YaHei" pitchFamily="34" charset="-122"/>
                 <a:cs typeface="Microsoft YaHei" pitchFamily="34" charset="-120"/>
               </a:rPr>
-              <a:t>TPM 安全文件保险箱课程设计答辩</a:t>
+              <a:t>TPM 安全文件保险箱</a:t>
             </a:r>
             <a:endParaRPr lang="en-US" sz="900" dirty="0"/>
           </a:p>
@@ -25059,7 +25110,7 @@
               </a:rPr>
               <a:t>done</a:t>
             </a:r>
-            <a:endParaRPr lang="en-US" sz="1050" dirty="0"/>
+            <a:endParaRPr lang="en-US" sz="1000" dirty="0"/>
           </a:p>
         </p:txBody>
       </p:sp>
@@ -25662,7 +25713,7 @@
                 <a:ea typeface="Microsoft YaHei" pitchFamily="34" charset="-122"/>
                 <a:cs typeface="Microsoft YaHei" pitchFamily="34" charset="-120"/>
               </a:rPr>
-              <a:t>TPM 安全文件保险箱课程设计答辩</a:t>
+              <a:t>TPM 安全文件保险箱</a:t>
             </a:r>
             <a:endParaRPr lang="en-US" sz="900" dirty="0"/>
           </a:p>
@@ -26418,7 +26469,7 @@
               </a:rPr>
               <a:t> not-need-init,startup-clear</a:t>
             </a:r>
-            <a:endParaRPr lang="en-US" sz="1050" dirty="0"/>
+            <a:endParaRPr lang="en-US" sz="1000" dirty="0"/>
           </a:p>
         </p:txBody>
       </p:sp>
@@ -27115,7 +27166,7 @@
                 <a:ea typeface="Microsoft YaHei" pitchFamily="34" charset="-122"/>
                 <a:cs typeface="Microsoft YaHei" pitchFamily="34" charset="-120"/>
               </a:rPr>
-              <a:t>TPM 安全文件保险箱课程设计答辩</a:t>
+              <a:t>TPM 安全文件保险箱</a:t>
             </a:r>
             <a:endParaRPr lang="en-US" sz="900" dirty="0"/>
           </a:p>
@@ -27661,7 +27712,7 @@
               <a:buNone/>
             </a:pPr>
             <a:r>
-              <a:rPr lang="en-US" sz="1050" dirty="0">
+              <a:rPr lang="en-US" sz="880" dirty="0">
                 <a:solidFill>
                   <a:srgbClr val="24364B"/>
                 </a:solidFill>
@@ -27669,16 +27720,16 @@
                 <a:ea typeface="Consolas" pitchFamily="34" charset="-122"/>
                 <a:cs typeface="Consolas" pitchFamily="34" charset="-120"/>
               </a:rPr>
-              <a:t>初始: 10:0x0000000000000000000000000000000000000000000000000000000000000000</a:t>
-            </a:r>
-            <a:endParaRPr lang="en-US" sz="1050" dirty="0"/>
-          </a:p>
-          <a:p>
-            <a:pPr indent="0" marL="0">
-              <a:buNone/>
-            </a:pPr>
-            <a:r>
-              <a:rPr lang="en-US" sz="1050" dirty="0">
+              <a:t>初始 PCR10:</a:t>
+            </a:r>
+            <a:endParaRPr lang="en-US" sz="880" dirty="0"/>
+          </a:p>
+          <a:p>
+            <a:pPr indent="0" marL="0">
+              <a:buNone/>
+            </a:pPr>
+            <a:r>
+              <a:rPr lang="en-US" sz="880" dirty="0">
                 <a:solidFill>
                   <a:srgbClr val="24364B"/>
                 </a:solidFill>
@@ -27686,16 +27737,22 @@
                 <a:ea typeface="Consolas" pitchFamily="34" charset="-122"/>
                 <a:cs typeface="Consolas" pitchFamily="34" charset="-120"/>
               </a:rPr>
-              <a:t>第一次扩展后: 10:0x85CCFB9AE4A72E3CB0A96067E37A262D3DFACEA94F1595F18B46F06F1471E0A0</a:t>
-            </a:r>
-            <a:endParaRPr lang="en-US" sz="1050" dirty="0"/>
-          </a:p>
-          <a:p>
-            <a:pPr indent="0" marL="0">
-              <a:buNone/>
-            </a:pPr>
-            <a:r>
-              <a:rPr lang="en-US" sz="1050" dirty="0">
+              <a:t>10:0x0000000000000000000000000000000000000000000000000000000000000000</a:t>
+            </a:r>
+            <a:endParaRPr lang="en-US" sz="880" dirty="0"/>
+          </a:p>
+          <a:p>
+            <a:pPr indent="0" marL="0">
+              <a:buNone/>
+            </a:pPr>
+            <a:endParaRPr lang="en-US" sz="880" dirty="0"/>
+          </a:p>
+          <a:p>
+            <a:pPr indent="0" marL="0">
+              <a:buNone/>
+            </a:pPr>
+            <a:r>
+              <a:rPr lang="en-US" sz="880" dirty="0">
                 <a:solidFill>
                   <a:srgbClr val="24364B"/>
                 </a:solidFill>
@@ -27703,16 +27760,16 @@
                 <a:ea typeface="Consolas" pitchFamily="34" charset="-122"/>
                 <a:cs typeface="Consolas" pitchFamily="34" charset="-120"/>
               </a:rPr>
-              <a:t>篡改后文件哈希: 9ed9ed5f34fbd3ad1410370f771b26027505dfcc098eb0ef00df4f9d5c97b9f1</a:t>
-            </a:r>
-            <a:endParaRPr lang="en-US" sz="1050" dirty="0"/>
-          </a:p>
-          <a:p>
-            <a:pPr indent="0" marL="0">
-              <a:buNone/>
-            </a:pPr>
-            <a:r>
-              <a:rPr lang="en-US" sz="1050" dirty="0">
+              <a:t>第一次扩展后:</a:t>
+            </a:r>
+            <a:endParaRPr lang="en-US" sz="880" dirty="0"/>
+          </a:p>
+          <a:p>
+            <a:pPr indent="0" marL="0">
+              <a:buNone/>
+            </a:pPr>
+            <a:r>
+              <a:rPr lang="en-US" sz="880" dirty="0">
                 <a:solidFill>
                   <a:srgbClr val="24364B"/>
                 </a:solidFill>
@@ -27720,9 +27777,140 @@
                 <a:ea typeface="Consolas" pitchFamily="34" charset="-122"/>
                 <a:cs typeface="Consolas" pitchFamily="34" charset="-120"/>
               </a:rPr>
-              <a:t>第二次扩展后: 10:0x2CD101015684E104C032ED6FE458CA4A6EA55686AF7CC0B7367A7D8C6D895E62</a:t>
-            </a:r>
-            <a:endParaRPr lang="en-US" sz="1050" dirty="0"/>
+              <a:t>10:0x85CCFB9AE4A72E3CB0A96067E37A262D</a:t>
+            </a:r>
+            <a:endParaRPr lang="en-US" sz="880" dirty="0"/>
+          </a:p>
+          <a:p>
+            <a:pPr indent="0" marL="0">
+              <a:buNone/>
+            </a:pPr>
+            <a:r>
+              <a:rPr lang="en-US" sz="880" dirty="0">
+                <a:solidFill>
+                  <a:srgbClr val="24364B"/>
+                </a:solidFill>
+                <a:latin typeface="Consolas" pitchFamily="34" charset="0"/>
+                <a:ea typeface="Consolas" pitchFamily="34" charset="-122"/>
+                <a:cs typeface="Consolas" pitchFamily="34" charset="-120"/>
+              </a:rPr>
+              <a:t>   3DFACEA94F1595F18B46F06F1471E0A0</a:t>
+            </a:r>
+            <a:endParaRPr lang="en-US" sz="880" dirty="0"/>
+          </a:p>
+          <a:p>
+            <a:pPr indent="0" marL="0">
+              <a:buNone/>
+            </a:pPr>
+            <a:endParaRPr lang="en-US" sz="880" dirty="0"/>
+          </a:p>
+          <a:p>
+            <a:pPr indent="0" marL="0">
+              <a:buNone/>
+            </a:pPr>
+            <a:r>
+              <a:rPr lang="en-US" sz="880" dirty="0">
+                <a:solidFill>
+                  <a:srgbClr val="24364B"/>
+                </a:solidFill>
+                <a:latin typeface="Consolas" pitchFamily="34" charset="0"/>
+                <a:ea typeface="Consolas" pitchFamily="34" charset="-122"/>
+                <a:cs typeface="Consolas" pitchFamily="34" charset="-120"/>
+              </a:rPr>
+              <a:t>篡改后文件哈希:</a:t>
+            </a:r>
+            <a:endParaRPr lang="en-US" sz="880" dirty="0"/>
+          </a:p>
+          <a:p>
+            <a:pPr indent="0" marL="0">
+              <a:buNone/>
+            </a:pPr>
+            <a:r>
+              <a:rPr lang="en-US" sz="880" dirty="0">
+                <a:solidFill>
+                  <a:srgbClr val="24364B"/>
+                </a:solidFill>
+                <a:latin typeface="Consolas" pitchFamily="34" charset="0"/>
+                <a:ea typeface="Consolas" pitchFamily="34" charset="-122"/>
+                <a:cs typeface="Consolas" pitchFamily="34" charset="-120"/>
+              </a:rPr>
+              <a:t>9ed9ed5f34fbd3ad1410370f771b2602</a:t>
+            </a:r>
+            <a:endParaRPr lang="en-US" sz="880" dirty="0"/>
+          </a:p>
+          <a:p>
+            <a:pPr indent="0" marL="0">
+              <a:buNone/>
+            </a:pPr>
+            <a:r>
+              <a:rPr lang="en-US" sz="880" dirty="0">
+                <a:solidFill>
+                  <a:srgbClr val="24364B"/>
+                </a:solidFill>
+                <a:latin typeface="Consolas" pitchFamily="34" charset="0"/>
+                <a:ea typeface="Consolas" pitchFamily="34" charset="-122"/>
+                <a:cs typeface="Consolas" pitchFamily="34" charset="-120"/>
+              </a:rPr>
+              <a:t>7505dfcc098eb0ef00df4f9d5c97b9f1</a:t>
+            </a:r>
+            <a:endParaRPr lang="en-US" sz="880" dirty="0"/>
+          </a:p>
+          <a:p>
+            <a:pPr indent="0" marL="0">
+              <a:buNone/>
+            </a:pPr>
+            <a:endParaRPr lang="en-US" sz="880" dirty="0"/>
+          </a:p>
+          <a:p>
+            <a:pPr indent="0" marL="0">
+              <a:buNone/>
+            </a:pPr>
+            <a:r>
+              <a:rPr lang="en-US" sz="880" dirty="0">
+                <a:solidFill>
+                  <a:srgbClr val="24364B"/>
+                </a:solidFill>
+                <a:latin typeface="Consolas" pitchFamily="34" charset="0"/>
+                <a:ea typeface="Consolas" pitchFamily="34" charset="-122"/>
+                <a:cs typeface="Consolas" pitchFamily="34" charset="-120"/>
+              </a:rPr>
+              <a:t>第二次扩展后:</a:t>
+            </a:r>
+            <a:endParaRPr lang="en-US" sz="880" dirty="0"/>
+          </a:p>
+          <a:p>
+            <a:pPr indent="0" marL="0">
+              <a:buNone/>
+            </a:pPr>
+            <a:r>
+              <a:rPr lang="en-US" sz="880" dirty="0">
+                <a:solidFill>
+                  <a:srgbClr val="24364B"/>
+                </a:solidFill>
+                <a:latin typeface="Consolas" pitchFamily="34" charset="0"/>
+                <a:ea typeface="Consolas" pitchFamily="34" charset="-122"/>
+                <a:cs typeface="Consolas" pitchFamily="34" charset="-120"/>
+              </a:rPr>
+              <a:t>10:0x2CD101015684E104C032ED6FE458CA4A</a:t>
+            </a:r>
+            <a:endParaRPr lang="en-US" sz="880" dirty="0"/>
+          </a:p>
+          <a:p>
+            <a:pPr indent="0" marL="0">
+              <a:buNone/>
+            </a:pPr>
+            <a:r>
+              <a:rPr lang="en-US" sz="880" dirty="0">
+                <a:solidFill>
+                  <a:srgbClr val="24364B"/>
+                </a:solidFill>
+                <a:latin typeface="Consolas" pitchFamily="34" charset="0"/>
+                <a:ea typeface="Consolas" pitchFamily="34" charset="-122"/>
+                <a:cs typeface="Consolas" pitchFamily="34" charset="-120"/>
+              </a:rPr>
+              <a:t>   6EA55686AF7CC0B7367A7D8C6D895E62</a:t>
+            </a:r>
+            <a:endParaRPr lang="en-US" sz="880" dirty="0"/>
           </a:p>
         </p:txBody>
       </p:sp>
@@ -28152,7 +28340,7 @@
                 <a:ea typeface="Microsoft YaHei" pitchFamily="34" charset="-122"/>
                 <a:cs typeface="Microsoft YaHei" pitchFamily="34" charset="-120"/>
               </a:rPr>
-              <a:t>TPM 安全文件保险箱课程设计答辩</a:t>
+              <a:t>TPM 安全文件保险箱</a:t>
             </a:r>
             <a:endParaRPr lang="en-US" sz="900" dirty="0"/>
           </a:p>
@@ -29306,7 +29494,7 @@
               </a:rPr>
               <a:t>"</a:t>
             </a:r>
-            <a:endParaRPr lang="en-US" sz="1050" dirty="0"/>
+            <a:endParaRPr lang="en-US" sz="1000" dirty="0"/>
           </a:p>
         </p:txBody>
       </p:sp>

</xml_diff>